<commit_message>
docs(deck): drop efficiency claim, frame gate as no-retraining
Weakness slide no longer cites unmeasured efficiency; uses the honest
scope limitation (2 tasks x 2 models) instead. Next-steps swaps
"measure speed/cost" for "more datasets and tasks". No-retraining
remains the deployment claim throughout.

Co-Authored-By: Claude Opus 4.8 <noreply@anthropic.com>
</commit_message>
<xml_diff>
--- a/presentation/SENTRY_results_discussion.pptx
+++ b/presentation/SENTRY_results_discussion.pptx
@@ -10386,7 +10386,7 @@
                 <a:ea typeface="Calibri" pitchFamily="34" charset="-122"/>
                 <a:cs typeface="Calibri" pitchFamily="34" charset="-120"/>
               </a:rPr>
-              <a:t>Efficiency not yet measured</a:t>
+              <a:t>Evaluated on 2 tasks × 2 models</a:t>
             </a:r>
             <a:endParaRPr lang="en-US" sz="1400" dirty="0"/>
           </a:p>
@@ -10567,7 +10567,7 @@
                 <a:ea typeface="Calibri" pitchFamily="34" charset="-122"/>
                 <a:cs typeface="Calibri" pitchFamily="34" charset="-120"/>
               </a:rPr>
-              <a:t>Measure speed / cost savings</a:t>
+              <a:t>More datasets and tasks</a:t>
             </a:r>
             <a:endParaRPr lang="en-US" sz="1400" dirty="0"/>
           </a:p>

</xml_diff>

<commit_message>
Reframe SENTRY as a training-free reliability framework; clean repo for submission
Reliability-framework framing (calibration on every task; accuracy+calibration
together on separable tasks; selective abstention; never-harm fallback), with the
separability characterisation as the scope of when retrieval engages.

- analysis/: study + comparison scripts over frozen embeddings (7 datasets x 4
  encoders) incl. BigCloneBench clone-detection control.
- kNN-Prediction/: grid drivers (run_grid, methods_grid, embed_clone); fix
  knn_predictor neighbour-count bug for small datastores.
- Docs: README, RELATED_WORK, VERIFIED_RESULTS, REPRODUCE, FINAL_VERDICT and the
  Results & Analysis chapter updated to corrected, verified numbers.
- Remove unused spt_simulator/spt_data, dead aggregate.py, superseded plan doc;
  gitignore regenerable embedding caches.
</commit_message>
<xml_diff>
--- a/presentation/SENTRY_results_discussion.pptx
+++ b/presentation/SENTRY_results_discussion.pptx
@@ -7843,7 +7843,7 @@
               <a:buNone/>
             </a:pPr>
             <a:r>
-              <a:rPr lang="en-US" sz="1300" i="1" dirty="0">
+              <a:rPr lang="en-US" sz="1200" i="1" dirty="0">
                 <a:solidFill>
                   <a:srgbClr val="6B7785"/>
                 </a:solidFill>
@@ -7851,9 +7851,9 @@
                 <a:ea typeface="Calibri" pitchFamily="34" charset="-122"/>
                 <a:cs typeface="Calibri" pitchFamily="34" charset="-120"/>
               </a:rPr>
-              <a:t>Retrieval helps iff the representation separates classes — the gate’s reliability signal predicts which.</a:t>
-            </a:r>
-            <a:endParaRPr lang="en-US" sz="1300" dirty="0"/>
+              <a:t>Retrieval helps iff the embedding separates classes — multiclass AND binary clone detection; it fails on vulnerability (unlearnable). The axis is separability, not binary-vs-multiclass.</a:t>
+            </a:r>
+            <a:endParaRPr lang="en-US" sz="1200" dirty="0"/>
           </a:p>
         </p:txBody>
       </p:sp>
@@ -9750,7 +9750,7 @@
                 <a:ea typeface="Calibri" pitchFamily="34" charset="-122"/>
                 <a:cs typeface="Calibri" pitchFamily="34" charset="-120"/>
               </a:rPr>
-              <a:t>* vulnerability task. SENTRY does not claim accuracy SOTA — it adds trust on a comparable base, and complements CodeImprove.</a:t>
+              <a:t>* vulnerability task. SENTRY adds calibration and reliability-gated accuracy on a comparable base — complementary to post-hoc calibration (incl. kNN-UE, NAACL’25) and to input-side CodeImprove.</a:t>
             </a:r>
             <a:endParaRPr lang="en-US" sz="1100" dirty="0"/>
           </a:p>
@@ -10142,7 +10142,7 @@
                 <a:ea typeface="Calibri" pitchFamily="34" charset="-122"/>
                 <a:cs typeface="Calibri" pitchFamily="34" charset="-120"/>
               </a:rPr>
-              <a:t>Training-free, model-agnostic</a:t>
+              <a:t>Accuracy + calibration together, no retraining</a:t>
             </a:r>
             <a:endParaRPr lang="en-US" sz="1400" dirty="0"/>
           </a:p>
@@ -10163,7 +10163,7 @@
                 <a:ea typeface="Calibri" pitchFamily="34" charset="-122"/>
                 <a:cs typeface="Calibri" pitchFamily="34" charset="-120"/>
               </a:rPr>
-              <a:t>Honest confidence (calibrated)</a:t>
+              <a:t>Significant defect gain (McNemar p=4e-6)</a:t>
             </a:r>
             <a:endParaRPr lang="en-US" sz="1400" dirty="0"/>
           </a:p>
@@ -10184,7 +10184,7 @@
                 <a:ea typeface="Calibri" pitchFamily="34" charset="-122"/>
                 <a:cs typeface="Calibri" pitchFamily="34" charset="-120"/>
               </a:rPr>
-              <a:t>Significant defect-task gain</a:t>
+              <a:t>7 datasets × 4 encoders; clone control</a:t>
             </a:r>
             <a:endParaRPr lang="en-US" sz="1400" dirty="0"/>
           </a:p>
@@ -10344,7 +10344,7 @@
                 <a:ea typeface="Calibri" pitchFamily="34" charset="-122"/>
                 <a:cs typeface="Calibri" pitchFamily="34" charset="-120"/>
               </a:rPr>
-              <a:t>Binary tasks not yet helped</a:t>
+              <a:t>Retrieval can’t help non-separable tasks (vuln)</a:t>
             </a:r>
             <a:endParaRPr lang="en-US" sz="1400" dirty="0"/>
           </a:p>
@@ -10365,7 +10365,7 @@
                 <a:ea typeface="Calibri" pitchFamily="34" charset="-122"/>
                 <a:cs typeface="Calibri" pitchFamily="34" charset="-120"/>
               </a:rPr>
-              <a:t>Not accuracy state-of-the-art</a:t>
+              <a:t>Separability seen post-hoc, not predicted</a:t>
             </a:r>
             <a:endParaRPr lang="en-US" sz="1400" dirty="0"/>
           </a:p>
@@ -10386,7 +10386,7 @@
                 <a:ea typeface="Calibri" pitchFamily="34" charset="-122"/>
                 <a:cs typeface="Calibri" pitchFamily="34" charset="-120"/>
               </a:rPr>
-              <a:t>Evaluated on 2 tasks × 2 models</a:t>
+              <a:t>Vulnerability = representability ceiling (data)</a:t>
             </a:r>
             <a:endParaRPr lang="en-US" sz="1400" dirty="0"/>
           </a:p>
@@ -10546,7 +10546,7 @@
                 <a:ea typeface="Calibri" pitchFamily="34" charset="-122"/>
                 <a:cs typeface="Calibri" pitchFamily="34" charset="-120"/>
               </a:rPr>
-              <a:t>Better gate for yes/no tasks</a:t>
+              <a:t>Auto-gate from the separability signal</a:t>
             </a:r>
             <a:endParaRPr lang="en-US" sz="1400" dirty="0"/>
           </a:p>
@@ -10567,7 +10567,7 @@
                 <a:ea typeface="Calibri" pitchFamily="34" charset="-122"/>
                 <a:cs typeface="Calibri" pitchFamily="34" charset="-120"/>
               </a:rPr>
-              <a:t>More datasets and tasks</a:t>
+              <a:t>Compose with uncertainty estimators (kNN-UE)</a:t>
             </a:r>
             <a:endParaRPr lang="en-US" sz="1400" dirty="0"/>
           </a:p>
@@ -10588,7 +10588,7 @@
                 <a:ea typeface="Calibri" pitchFamily="34" charset="-122"/>
                 <a:cs typeface="Calibri" pitchFamily="34" charset="-120"/>
               </a:rPr>
-              <a:t>Combine with CodeImprove</a:t>
+              <a:t>Broaden tasks; combine with CodeImprove</a:t>
             </a:r>
             <a:endParaRPr lang="en-US" sz="1400" dirty="0"/>
           </a:p>

</xml_diff>

<commit_message>
deck: fix misleading numbers — real conf/acc gap, honest ECE worst-case label, clean per-model defect table (drop vuln-in-defect-column, 84%->83.1/83.5), un-exaggerate bar axis
</commit_message>
<xml_diff>
--- a/presentation/SENTRY_results_discussion.pptx
+++ b/presentation/SENTRY_results_discussion.pptx
@@ -339,8 +339,8 @@
         <c:axId val="2094734552"/>
         <c:scaling>
           <c:orientation val="minMax"/>
-          <c:max val="84"/>
-          <c:min val="74"/>
+          <c:max val="90"/>
+          <c:min val="70"/>
         </c:scaling>
         <c:delete val="1"/>
         <c:axPos val="l"/>
@@ -9765,7 +9765,7 @@
               <a:buNone/>
             </a:pPr>
             <a:r>
-              <a:rPr lang="en-US" sz="1500" b="1" dirty="0">
+              <a:rPr lang="en-US" sz="1400" b="1" dirty="0">
                 <a:solidFill>
                   <a:srgbClr val="C0392B"/>
                 </a:solidFill>
@@ -9773,9 +9773,9 @@
                 <a:ea typeface="Calibri" pitchFamily="34" charset="-122"/>
                 <a:cs typeface="Calibri" pitchFamily="34" charset="-120"/>
               </a:rPr>
-              <a:t>Before</a:t>
-            </a:r>
-            <a:endParaRPr lang="en-US" sz="1500" dirty="0"/>
+              <a:t>Before — worst case (vulnerability)</a:t>
+            </a:r>
+            <a:endParaRPr lang="en-US" sz="1400" dirty="0"/>
           </a:p>
         </p:txBody>
       </p:sp>
@@ -9812,7 +9812,7 @@
                 <a:ea typeface="Cambria" pitchFamily="34" charset="-122"/>
                 <a:cs typeface="Cambria" pitchFamily="34" charset="-120"/>
               </a:rPr>
-              <a:t>0.23</a:t>
+              <a:t>0.20</a:t>
             </a:r>
             <a:endParaRPr lang="en-US" sz="7200" dirty="0"/>
           </a:p>
@@ -16790,12 +16790,12 @@
             <a:tbl>
               <a:tblPr/>
               <a:tblGrid>
-                <a:gridCol w="3611880"/>
-                <a:gridCol w="2377440"/>
+                <a:gridCol w="4160520"/>
+                <a:gridCol w="2011680"/>
                 <a:gridCol w="3108960"/>
-                <a:gridCol w="1810512"/>
+                <a:gridCol w="1627632"/>
               </a:tblGrid>
-              <a:tr h="566928">
+              <a:tr h="548640">
                 <a:tc>
                   <a:txBody>
                     <a:bodyPr/>
@@ -16813,7 +16813,7 @@
                           <a:ea typeface="Calibri" pitchFamily="34" charset="-122"/>
                           <a:cs typeface="Calibri" pitchFamily="34" charset="-120"/>
                         </a:rPr>
-                        <a:t>Approach</a:t>
+                        <a:t>Approach (defect prediction)</a:t>
                       </a:r>
                       <a:endParaRPr lang="en-US" sz="1300" dirty="0">
                         <a:latin typeface="Calibri" charset="0"/>
@@ -16881,7 +16881,7 @@
                           <a:ea typeface="Calibri" pitchFamily="34" charset="-122"/>
                           <a:cs typeface="Calibri" pitchFamily="34" charset="-120"/>
                         </a:rPr>
-                        <a:t>Defect acc.</a:t>
+                        <a:t>Accuracy</a:t>
                       </a:r>
                       <a:endParaRPr lang="en-US" sz="1300" dirty="0">
                         <a:latin typeface="Calibri" charset="0"/>
@@ -16949,7 +16949,7 @@
                           <a:ea typeface="Calibri" pitchFamily="34" charset="-122"/>
                           <a:cs typeface="Calibri" pitchFamily="34" charset="-120"/>
                         </a:rPr>
-                        <a:t>Trust / calibration</a:t>
+                        <a:t>Calibration</a:t>
                       </a:r>
                       <a:endParaRPr lang="en-US" sz="1300" dirty="0">
                         <a:latin typeface="Calibri" charset="0"/>
@@ -17017,7 +17017,7 @@
                           <a:ea typeface="Calibri" pitchFamily="34" charset="-122"/>
                           <a:cs typeface="Calibri" pitchFamily="34" charset="-120"/>
                         </a:rPr>
-                        <a:t>Retraining</a:t>
+                        <a:t>Extra training</a:t>
                       </a:r>
                       <a:endParaRPr lang="en-US" sz="1300" dirty="0">
                         <a:latin typeface="Calibri" charset="0"/>
@@ -17069,7 +17069,7 @@
                   </a:tcPr>
                 </a:tc>
               </a:tr>
-              <a:tr h="566928">
+              <a:tr h="548640">
                 <a:tc>
                   <a:txBody>
                     <a:bodyPr/>
@@ -17087,7 +17087,7 @@
                           <a:ea typeface="Calibri" pitchFamily="34" charset="-122"/>
                           <a:cs typeface="Calibri" pitchFamily="34" charset="-120"/>
                         </a:rPr>
-                        <a:t>CodeBERT (base)</a:t>
+                        <a:t>CodeBERT — base</a:t>
                       </a:r>
                       <a:endParaRPr lang="en-US" sz="1300" dirty="0">
                         <a:latin typeface="Calibri" charset="0"/>
@@ -17152,7 +17152,7 @@
                           <a:ea typeface="Calibri" pitchFamily="34" charset="-122"/>
                           <a:cs typeface="Calibri" pitchFamily="34" charset="-120"/>
                         </a:rPr>
-                        <a:t>~82%</a:t>
+                        <a:t>81.8%</a:t>
                       </a:r>
                       <a:endParaRPr lang="en-US" sz="1300" dirty="0">
                         <a:latin typeface="Calibri" charset="0"/>
@@ -17282,7 +17282,7 @@
                           <a:ea typeface="Calibri" pitchFamily="34" charset="-122"/>
                           <a:cs typeface="Calibri" pitchFamily="34" charset="-120"/>
                         </a:rPr>
-                        <a:t>needed</a:t>
+                        <a:t>—</a:t>
                       </a:r>
                       <a:endParaRPr lang="en-US" sz="1300" dirty="0">
                         <a:latin typeface="Calibri" charset="0"/>
@@ -17331,793 +17331,7 @@
                   </a:tcPr>
                 </a:tc>
               </a:tr>
-              <a:tr h="566928">
-                <a:tc>
-                  <a:txBody>
-                    <a:bodyPr/>
-                    <a:lstStyle/>
-                    <a:p>
-                      <a:pPr algn="ctr" indent="0" marL="0">
-                        <a:buNone/>
-                      </a:pPr>
-                      <a:r>
-                        <a:rPr lang="en-US" sz="1300" dirty="0">
-                          <a:solidFill>
-                            <a:srgbClr val="33414F"/>
-                          </a:solidFill>
-                          <a:latin typeface="Calibri" pitchFamily="34" charset="0"/>
-                          <a:ea typeface="Calibri" pitchFamily="34" charset="-122"/>
-                          <a:cs typeface="Calibri" pitchFamily="34" charset="-120"/>
-                        </a:rPr>
-                        <a:t>GraphCodeBERT (base)</a:t>
-                      </a:r>
-                      <a:endParaRPr lang="en-US" sz="1300" dirty="0">
-                        <a:latin typeface="Calibri" charset="0"/>
-                        <a:ea typeface="Calibri" charset="0"/>
-                        <a:cs typeface="Calibri" charset="0"/>
-                      </a:endParaRPr>
-                    </a:p>
-                  </a:txBody>
-                  <a:tcPr marL="91440" marR="91440" marT="45720" marB="45720" anchor="ctr">
-                    <a:lnL w="12700" cap="flat" cmpd="sng" algn="ctr">
-                      <a:solidFill>
-                        <a:srgbClr val="DBE4E8"/>
-                      </a:solidFill>
-                      <a:prstDash val="solid"/>
-                      <a:round/>
-                      <a:headEnd type="none" w="med" len="med"/>
-                      <a:tailEnd type="none" w="med" len="med"/>
-                    </a:lnL>
-                    <a:lnR w="12700" cap="flat" cmpd="sng" algn="ctr">
-                      <a:solidFill>
-                        <a:srgbClr val="DBE4E8"/>
-                      </a:solidFill>
-                      <a:prstDash val="solid"/>
-                      <a:round/>
-                      <a:headEnd type="none" w="med" len="med"/>
-                      <a:tailEnd type="none" w="med" len="med"/>
-                    </a:lnR>
-                    <a:lnT w="12700" cap="flat" cmpd="sng" algn="ctr">
-                      <a:solidFill>
-                        <a:srgbClr val="DBE4E8"/>
-                      </a:solidFill>
-                      <a:prstDash val="solid"/>
-                      <a:round/>
-                      <a:headEnd type="none" w="med" len="med"/>
-                      <a:tailEnd type="none" w="med" len="med"/>
-                    </a:lnT>
-                    <a:lnB w="12700" cap="flat" cmpd="sng" algn="ctr">
-                      <a:solidFill>
-                        <a:srgbClr val="DBE4E8"/>
-                      </a:solidFill>
-                      <a:prstDash val="solid"/>
-                      <a:round/>
-                      <a:headEnd type="none" w="med" len="med"/>
-                      <a:tailEnd type="none" w="med" len="med"/>
-                    </a:lnB>
-                  </a:tcPr>
-                </a:tc>
-                <a:tc>
-                  <a:txBody>
-                    <a:bodyPr/>
-                    <a:lstStyle/>
-                    <a:p>
-                      <a:pPr algn="ctr" indent="0" marL="0">
-                        <a:buNone/>
-                      </a:pPr>
-                      <a:r>
-                        <a:rPr lang="en-US" sz="1300" dirty="0">
-                          <a:solidFill>
-                            <a:srgbClr val="33414F"/>
-                          </a:solidFill>
-                          <a:latin typeface="Calibri" pitchFamily="34" charset="0"/>
-                          <a:ea typeface="Calibri" pitchFamily="34" charset="-122"/>
-                          <a:cs typeface="Calibri" pitchFamily="34" charset="-120"/>
-                        </a:rPr>
-                        <a:t>~81%</a:t>
-                      </a:r>
-                      <a:endParaRPr lang="en-US" sz="1300" dirty="0">
-                        <a:latin typeface="Calibri" charset="0"/>
-                        <a:ea typeface="Calibri" charset="0"/>
-                        <a:cs typeface="Calibri" charset="0"/>
-                      </a:endParaRPr>
-                    </a:p>
-                  </a:txBody>
-                  <a:tcPr marL="91440" marR="91440" marT="45720" marB="45720" anchor="ctr">
-                    <a:lnL w="12700" cap="flat" cmpd="sng" algn="ctr">
-                      <a:solidFill>
-                        <a:srgbClr val="DBE4E8"/>
-                      </a:solidFill>
-                      <a:prstDash val="solid"/>
-                      <a:round/>
-                      <a:headEnd type="none" w="med" len="med"/>
-                      <a:tailEnd type="none" w="med" len="med"/>
-                    </a:lnL>
-                    <a:lnR w="12700" cap="flat" cmpd="sng" algn="ctr">
-                      <a:solidFill>
-                        <a:srgbClr val="DBE4E8"/>
-                      </a:solidFill>
-                      <a:prstDash val="solid"/>
-                      <a:round/>
-                      <a:headEnd type="none" w="med" len="med"/>
-                      <a:tailEnd type="none" w="med" len="med"/>
-                    </a:lnR>
-                    <a:lnT w="12700" cap="flat" cmpd="sng" algn="ctr">
-                      <a:solidFill>
-                        <a:srgbClr val="DBE4E8"/>
-                      </a:solidFill>
-                      <a:prstDash val="solid"/>
-                      <a:round/>
-                      <a:headEnd type="none" w="med" len="med"/>
-                      <a:tailEnd type="none" w="med" len="med"/>
-                    </a:lnT>
-                    <a:lnB w="12700" cap="flat" cmpd="sng" algn="ctr">
-                      <a:solidFill>
-                        <a:srgbClr val="DBE4E8"/>
-                      </a:solidFill>
-                      <a:prstDash val="solid"/>
-                      <a:round/>
-                      <a:headEnd type="none" w="med" len="med"/>
-                      <a:tailEnd type="none" w="med" len="med"/>
-                    </a:lnB>
-                  </a:tcPr>
-                </a:tc>
-                <a:tc>
-                  <a:txBody>
-                    <a:bodyPr/>
-                    <a:lstStyle/>
-                    <a:p>
-                      <a:pPr algn="ctr" indent="0" marL="0">
-                        <a:buNone/>
-                      </a:pPr>
-                      <a:r>
-                        <a:rPr lang="en-US" sz="1300" dirty="0">
-                          <a:solidFill>
-                            <a:srgbClr val="33414F"/>
-                          </a:solidFill>
-                          <a:latin typeface="Calibri" pitchFamily="34" charset="0"/>
-                          <a:ea typeface="Calibri" pitchFamily="34" charset="-122"/>
-                          <a:cs typeface="Calibri" pitchFamily="34" charset="-120"/>
-                        </a:rPr>
-                        <a:t>✗ overconfident</a:t>
-                      </a:r>
-                      <a:endParaRPr lang="en-US" sz="1300" dirty="0">
-                        <a:latin typeface="Calibri" charset="0"/>
-                        <a:ea typeface="Calibri" charset="0"/>
-                        <a:cs typeface="Calibri" charset="0"/>
-                      </a:endParaRPr>
-                    </a:p>
-                  </a:txBody>
-                  <a:tcPr marL="91440" marR="91440" marT="45720" marB="45720" anchor="ctr">
-                    <a:lnL w="12700" cap="flat" cmpd="sng" algn="ctr">
-                      <a:solidFill>
-                        <a:srgbClr val="DBE4E8"/>
-                      </a:solidFill>
-                      <a:prstDash val="solid"/>
-                      <a:round/>
-                      <a:headEnd type="none" w="med" len="med"/>
-                      <a:tailEnd type="none" w="med" len="med"/>
-                    </a:lnL>
-                    <a:lnR w="12700" cap="flat" cmpd="sng" algn="ctr">
-                      <a:solidFill>
-                        <a:srgbClr val="DBE4E8"/>
-                      </a:solidFill>
-                      <a:prstDash val="solid"/>
-                      <a:round/>
-                      <a:headEnd type="none" w="med" len="med"/>
-                      <a:tailEnd type="none" w="med" len="med"/>
-                    </a:lnR>
-                    <a:lnT w="12700" cap="flat" cmpd="sng" algn="ctr">
-                      <a:solidFill>
-                        <a:srgbClr val="DBE4E8"/>
-                      </a:solidFill>
-                      <a:prstDash val="solid"/>
-                      <a:round/>
-                      <a:headEnd type="none" w="med" len="med"/>
-                      <a:tailEnd type="none" w="med" len="med"/>
-                    </a:lnT>
-                    <a:lnB w="12700" cap="flat" cmpd="sng" algn="ctr">
-                      <a:solidFill>
-                        <a:srgbClr val="DBE4E8"/>
-                      </a:solidFill>
-                      <a:prstDash val="solid"/>
-                      <a:round/>
-                      <a:headEnd type="none" w="med" len="med"/>
-                      <a:tailEnd type="none" w="med" len="med"/>
-                    </a:lnB>
-                  </a:tcPr>
-                </a:tc>
-                <a:tc>
-                  <a:txBody>
-                    <a:bodyPr/>
-                    <a:lstStyle/>
-                    <a:p>
-                      <a:pPr algn="ctr" indent="0" marL="0">
-                        <a:buNone/>
-                      </a:pPr>
-                      <a:r>
-                        <a:rPr lang="en-US" sz="1300" dirty="0">
-                          <a:solidFill>
-                            <a:srgbClr val="33414F"/>
-                          </a:solidFill>
-                          <a:latin typeface="Calibri" pitchFamily="34" charset="0"/>
-                          <a:ea typeface="Calibri" pitchFamily="34" charset="-122"/>
-                          <a:cs typeface="Calibri" pitchFamily="34" charset="-120"/>
-                        </a:rPr>
-                        <a:t>needed</a:t>
-                      </a:r>
-                      <a:endParaRPr lang="en-US" sz="1300" dirty="0">
-                        <a:latin typeface="Calibri" charset="0"/>
-                        <a:ea typeface="Calibri" charset="0"/>
-                        <a:cs typeface="Calibri" charset="0"/>
-                      </a:endParaRPr>
-                    </a:p>
-                  </a:txBody>
-                  <a:tcPr marL="91440" marR="91440" marT="45720" marB="45720" anchor="ctr">
-                    <a:lnL w="12700" cap="flat" cmpd="sng" algn="ctr">
-                      <a:solidFill>
-                        <a:srgbClr val="DBE4E8"/>
-                      </a:solidFill>
-                      <a:prstDash val="solid"/>
-                      <a:round/>
-                      <a:headEnd type="none" w="med" len="med"/>
-                      <a:tailEnd type="none" w="med" len="med"/>
-                    </a:lnL>
-                    <a:lnR w="12700" cap="flat" cmpd="sng" algn="ctr">
-                      <a:solidFill>
-                        <a:srgbClr val="DBE4E8"/>
-                      </a:solidFill>
-                      <a:prstDash val="solid"/>
-                      <a:round/>
-                      <a:headEnd type="none" w="med" len="med"/>
-                      <a:tailEnd type="none" w="med" len="med"/>
-                    </a:lnR>
-                    <a:lnT w="12700" cap="flat" cmpd="sng" algn="ctr">
-                      <a:solidFill>
-                        <a:srgbClr val="DBE4E8"/>
-                      </a:solidFill>
-                      <a:prstDash val="solid"/>
-                      <a:round/>
-                      <a:headEnd type="none" w="med" len="med"/>
-                      <a:tailEnd type="none" w="med" len="med"/>
-                    </a:lnT>
-                    <a:lnB w="12700" cap="flat" cmpd="sng" algn="ctr">
-                      <a:solidFill>
-                        <a:srgbClr val="DBE4E8"/>
-                      </a:solidFill>
-                      <a:prstDash val="solid"/>
-                      <a:round/>
-                      <a:headEnd type="none" w="med" len="med"/>
-                      <a:tailEnd type="none" w="med" len="med"/>
-                    </a:lnB>
-                  </a:tcPr>
-                </a:tc>
-              </a:tr>
-              <a:tr h="566928">
-                <a:tc>
-                  <a:txBody>
-                    <a:bodyPr/>
-                    <a:lstStyle/>
-                    <a:p>
-                      <a:pPr algn="ctr" indent="0" marL="0">
-                        <a:buNone/>
-                      </a:pPr>
-                      <a:r>
-                        <a:rPr lang="en-US" sz="1300" dirty="0">
-                          <a:solidFill>
-                            <a:srgbClr val="33414F"/>
-                          </a:solidFill>
-                          <a:latin typeface="Calibri" pitchFamily="34" charset="0"/>
-                          <a:ea typeface="Calibri" pitchFamily="34" charset="-122"/>
-                          <a:cs typeface="Calibri" pitchFamily="34" charset="-120"/>
-                        </a:rPr>
-                        <a:t>CodeImprove (ICSE’25)</a:t>
-                      </a:r>
-                      <a:endParaRPr lang="en-US" sz="1300" dirty="0">
-                        <a:latin typeface="Calibri" charset="0"/>
-                        <a:ea typeface="Calibri" charset="0"/>
-                        <a:cs typeface="Calibri" charset="0"/>
-                      </a:endParaRPr>
-                    </a:p>
-                  </a:txBody>
-                  <a:tcPr marL="91440" marR="91440" marT="45720" marB="45720" anchor="ctr">
-                    <a:lnL w="12700" cap="flat" cmpd="sng" algn="ctr">
-                      <a:solidFill>
-                        <a:srgbClr val="DBE4E8"/>
-                      </a:solidFill>
-                      <a:prstDash val="solid"/>
-                      <a:round/>
-                      <a:headEnd type="none" w="med" len="med"/>
-                      <a:tailEnd type="none" w="med" len="med"/>
-                    </a:lnL>
-                    <a:lnR w="12700" cap="flat" cmpd="sng" algn="ctr">
-                      <a:solidFill>
-                        <a:srgbClr val="DBE4E8"/>
-                      </a:solidFill>
-                      <a:prstDash val="solid"/>
-                      <a:round/>
-                      <a:headEnd type="none" w="med" len="med"/>
-                      <a:tailEnd type="none" w="med" len="med"/>
-                    </a:lnR>
-                    <a:lnT w="12700" cap="flat" cmpd="sng" algn="ctr">
-                      <a:solidFill>
-                        <a:srgbClr val="DBE4E8"/>
-                      </a:solidFill>
-                      <a:prstDash val="solid"/>
-                      <a:round/>
-                      <a:headEnd type="none" w="med" len="med"/>
-                      <a:tailEnd type="none" w="med" len="med"/>
-                    </a:lnT>
-                    <a:lnB w="12700" cap="flat" cmpd="sng" algn="ctr">
-                      <a:solidFill>
-                        <a:srgbClr val="DBE4E8"/>
-                      </a:solidFill>
-                      <a:prstDash val="solid"/>
-                      <a:round/>
-                      <a:headEnd type="none" w="med" len="med"/>
-                      <a:tailEnd type="none" w="med" len="med"/>
-                    </a:lnB>
-                  </a:tcPr>
-                </a:tc>
-                <a:tc>
-                  <a:txBody>
-                    <a:bodyPr/>
-                    <a:lstStyle/>
-                    <a:p>
-                      <a:pPr algn="ctr" indent="0" marL="0">
-                        <a:buNone/>
-                      </a:pPr>
-                      <a:r>
-                        <a:rPr lang="en-US" sz="1300" dirty="0">
-                          <a:solidFill>
-                            <a:srgbClr val="33414F"/>
-                          </a:solidFill>
-                          <a:latin typeface="Calibri" pitchFamily="34" charset="0"/>
-                          <a:ea typeface="Calibri" pitchFamily="34" charset="-122"/>
-                          <a:cs typeface="Calibri" pitchFamily="34" charset="-120"/>
-                        </a:rPr>
-                        <a:t>~82%</a:t>
-                      </a:r>
-                      <a:endParaRPr lang="en-US" sz="1300" dirty="0">
-                        <a:latin typeface="Calibri" charset="0"/>
-                        <a:ea typeface="Calibri" charset="0"/>
-                        <a:cs typeface="Calibri" charset="0"/>
-                      </a:endParaRPr>
-                    </a:p>
-                  </a:txBody>
-                  <a:tcPr marL="91440" marR="91440" marT="45720" marB="45720" anchor="ctr">
-                    <a:lnL w="12700" cap="flat" cmpd="sng" algn="ctr">
-                      <a:solidFill>
-                        <a:srgbClr val="DBE4E8"/>
-                      </a:solidFill>
-                      <a:prstDash val="solid"/>
-                      <a:round/>
-                      <a:headEnd type="none" w="med" len="med"/>
-                      <a:tailEnd type="none" w="med" len="med"/>
-                    </a:lnL>
-                    <a:lnR w="12700" cap="flat" cmpd="sng" algn="ctr">
-                      <a:solidFill>
-                        <a:srgbClr val="DBE4E8"/>
-                      </a:solidFill>
-                      <a:prstDash val="solid"/>
-                      <a:round/>
-                      <a:headEnd type="none" w="med" len="med"/>
-                      <a:tailEnd type="none" w="med" len="med"/>
-                    </a:lnR>
-                    <a:lnT w="12700" cap="flat" cmpd="sng" algn="ctr">
-                      <a:solidFill>
-                        <a:srgbClr val="DBE4E8"/>
-                      </a:solidFill>
-                      <a:prstDash val="solid"/>
-                      <a:round/>
-                      <a:headEnd type="none" w="med" len="med"/>
-                      <a:tailEnd type="none" w="med" len="med"/>
-                    </a:lnT>
-                    <a:lnB w="12700" cap="flat" cmpd="sng" algn="ctr">
-                      <a:solidFill>
-                        <a:srgbClr val="DBE4E8"/>
-                      </a:solidFill>
-                      <a:prstDash val="solid"/>
-                      <a:round/>
-                      <a:headEnd type="none" w="med" len="med"/>
-                      <a:tailEnd type="none" w="med" len="med"/>
-                    </a:lnB>
-                  </a:tcPr>
-                </a:tc>
-                <a:tc>
-                  <a:txBody>
-                    <a:bodyPr/>
-                    <a:lstStyle/>
-                    <a:p>
-                      <a:pPr algn="ctr" indent="0" marL="0">
-                        <a:buNone/>
-                      </a:pPr>
-                      <a:r>
-                        <a:rPr lang="en-US" sz="1300" dirty="0">
-                          <a:solidFill>
-                            <a:srgbClr val="33414F"/>
-                          </a:solidFill>
-                          <a:latin typeface="Calibri" pitchFamily="34" charset="0"/>
-                          <a:ea typeface="Calibri" pitchFamily="34" charset="-122"/>
-                          <a:cs typeface="Calibri" pitchFamily="34" charset="-120"/>
-                        </a:rPr>
-                        <a:t>— not addressed</a:t>
-                      </a:r>
-                      <a:endParaRPr lang="en-US" sz="1300" dirty="0">
-                        <a:latin typeface="Calibri" charset="0"/>
-                        <a:ea typeface="Calibri" charset="0"/>
-                        <a:cs typeface="Calibri" charset="0"/>
-                      </a:endParaRPr>
-                    </a:p>
-                  </a:txBody>
-                  <a:tcPr marL="91440" marR="91440" marT="45720" marB="45720" anchor="ctr">
-                    <a:lnL w="12700" cap="flat" cmpd="sng" algn="ctr">
-                      <a:solidFill>
-                        <a:srgbClr val="DBE4E8"/>
-                      </a:solidFill>
-                      <a:prstDash val="solid"/>
-                      <a:round/>
-                      <a:headEnd type="none" w="med" len="med"/>
-                      <a:tailEnd type="none" w="med" len="med"/>
-                    </a:lnL>
-                    <a:lnR w="12700" cap="flat" cmpd="sng" algn="ctr">
-                      <a:solidFill>
-                        <a:srgbClr val="DBE4E8"/>
-                      </a:solidFill>
-                      <a:prstDash val="solid"/>
-                      <a:round/>
-                      <a:headEnd type="none" w="med" len="med"/>
-                      <a:tailEnd type="none" w="med" len="med"/>
-                    </a:lnR>
-                    <a:lnT w="12700" cap="flat" cmpd="sng" algn="ctr">
-                      <a:solidFill>
-                        <a:srgbClr val="DBE4E8"/>
-                      </a:solidFill>
-                      <a:prstDash val="solid"/>
-                      <a:round/>
-                      <a:headEnd type="none" w="med" len="med"/>
-                      <a:tailEnd type="none" w="med" len="med"/>
-                    </a:lnT>
-                    <a:lnB w="12700" cap="flat" cmpd="sng" algn="ctr">
-                      <a:solidFill>
-                        <a:srgbClr val="DBE4E8"/>
-                      </a:solidFill>
-                      <a:prstDash val="solid"/>
-                      <a:round/>
-                      <a:headEnd type="none" w="med" len="med"/>
-                      <a:tailEnd type="none" w="med" len="med"/>
-                    </a:lnB>
-                  </a:tcPr>
-                </a:tc>
-                <a:tc>
-                  <a:txBody>
-                    <a:bodyPr/>
-                    <a:lstStyle/>
-                    <a:p>
-                      <a:pPr algn="ctr" indent="0" marL="0">
-                        <a:buNone/>
-                      </a:pPr>
-                      <a:r>
-                        <a:rPr lang="en-US" sz="1300" dirty="0">
-                          <a:solidFill>
-                            <a:srgbClr val="33414F"/>
-                          </a:solidFill>
-                          <a:latin typeface="Calibri" pitchFamily="34" charset="0"/>
-                          <a:ea typeface="Calibri" pitchFamily="34" charset="-122"/>
-                          <a:cs typeface="Calibri" pitchFamily="34" charset="-120"/>
-                        </a:rPr>
-                        <a:t>none</a:t>
-                      </a:r>
-                      <a:endParaRPr lang="en-US" sz="1300" dirty="0">
-                        <a:latin typeface="Calibri" charset="0"/>
-                        <a:ea typeface="Calibri" charset="0"/>
-                        <a:cs typeface="Calibri" charset="0"/>
-                      </a:endParaRPr>
-                    </a:p>
-                  </a:txBody>
-                  <a:tcPr marL="91440" marR="91440" marT="45720" marB="45720" anchor="ctr">
-                    <a:lnL w="12700" cap="flat" cmpd="sng" algn="ctr">
-                      <a:solidFill>
-                        <a:srgbClr val="DBE4E8"/>
-                      </a:solidFill>
-                      <a:prstDash val="solid"/>
-                      <a:round/>
-                      <a:headEnd type="none" w="med" len="med"/>
-                      <a:tailEnd type="none" w="med" len="med"/>
-                    </a:lnL>
-                    <a:lnR w="12700" cap="flat" cmpd="sng" algn="ctr">
-                      <a:solidFill>
-                        <a:srgbClr val="DBE4E8"/>
-                      </a:solidFill>
-                      <a:prstDash val="solid"/>
-                      <a:round/>
-                      <a:headEnd type="none" w="med" len="med"/>
-                      <a:tailEnd type="none" w="med" len="med"/>
-                    </a:lnR>
-                    <a:lnT w="12700" cap="flat" cmpd="sng" algn="ctr">
-                      <a:solidFill>
-                        <a:srgbClr val="DBE4E8"/>
-                      </a:solidFill>
-                      <a:prstDash val="solid"/>
-                      <a:round/>
-                      <a:headEnd type="none" w="med" len="med"/>
-                      <a:tailEnd type="none" w="med" len="med"/>
-                    </a:lnT>
-                    <a:lnB w="12700" cap="flat" cmpd="sng" algn="ctr">
-                      <a:solidFill>
-                        <a:srgbClr val="DBE4E8"/>
-                      </a:solidFill>
-                      <a:prstDash val="solid"/>
-                      <a:round/>
-                      <a:headEnd type="none" w="med" len="med"/>
-                      <a:tailEnd type="none" w="med" len="med"/>
-                    </a:lnB>
-                  </a:tcPr>
-                </a:tc>
-              </a:tr>
-              <a:tr h="566928">
-                <a:tc>
-                  <a:txBody>
-                    <a:bodyPr/>
-                    <a:lstStyle/>
-                    <a:p>
-                      <a:pPr algn="ctr" indent="0" marL="0">
-                        <a:buNone/>
-                      </a:pPr>
-                      <a:r>
-                        <a:rPr lang="en-US" sz="1300" dirty="0">
-                          <a:solidFill>
-                            <a:srgbClr val="33414F"/>
-                          </a:solidFill>
-                          <a:latin typeface="Calibri" pitchFamily="34" charset="0"/>
-                          <a:ea typeface="Calibri" pitchFamily="34" charset="-122"/>
-                          <a:cs typeface="Calibri" pitchFamily="34" charset="-120"/>
-                        </a:rPr>
-                        <a:t>Devign SOTA (CodeT5…)</a:t>
-                      </a:r>
-                      <a:endParaRPr lang="en-US" sz="1300" dirty="0">
-                        <a:latin typeface="Calibri" charset="0"/>
-                        <a:ea typeface="Calibri" charset="0"/>
-                        <a:cs typeface="Calibri" charset="0"/>
-                      </a:endParaRPr>
-                    </a:p>
-                  </a:txBody>
-                  <a:tcPr marL="91440" marR="91440" marT="45720" marB="45720" anchor="ctr">
-                    <a:lnL w="12700" cap="flat" cmpd="sng" algn="ctr">
-                      <a:solidFill>
-                        <a:srgbClr val="DBE4E8"/>
-                      </a:solidFill>
-                      <a:prstDash val="solid"/>
-                      <a:round/>
-                      <a:headEnd type="none" w="med" len="med"/>
-                      <a:tailEnd type="none" w="med" len="med"/>
-                    </a:lnL>
-                    <a:lnR w="12700" cap="flat" cmpd="sng" algn="ctr">
-                      <a:solidFill>
-                        <a:srgbClr val="DBE4E8"/>
-                      </a:solidFill>
-                      <a:prstDash val="solid"/>
-                      <a:round/>
-                      <a:headEnd type="none" w="med" len="med"/>
-                      <a:tailEnd type="none" w="med" len="med"/>
-                    </a:lnR>
-                    <a:lnT w="12700" cap="flat" cmpd="sng" algn="ctr">
-                      <a:solidFill>
-                        <a:srgbClr val="DBE4E8"/>
-                      </a:solidFill>
-                      <a:prstDash val="solid"/>
-                      <a:round/>
-                      <a:headEnd type="none" w="med" len="med"/>
-                      <a:tailEnd type="none" w="med" len="med"/>
-                    </a:lnT>
-                    <a:lnB w="12700" cap="flat" cmpd="sng" algn="ctr">
-                      <a:solidFill>
-                        <a:srgbClr val="DBE4E8"/>
-                      </a:solidFill>
-                      <a:prstDash val="solid"/>
-                      <a:round/>
-                      <a:headEnd type="none" w="med" len="med"/>
-                      <a:tailEnd type="none" w="med" len="med"/>
-                    </a:lnB>
-                  </a:tcPr>
-                </a:tc>
-                <a:tc>
-                  <a:txBody>
-                    <a:bodyPr/>
-                    <a:lstStyle/>
-                    <a:p>
-                      <a:pPr algn="ctr" indent="0" marL="0">
-                        <a:buNone/>
-                      </a:pPr>
-                      <a:r>
-                        <a:rPr lang="en-US" sz="1300" dirty="0">
-                          <a:solidFill>
-                            <a:srgbClr val="33414F"/>
-                          </a:solidFill>
-                          <a:latin typeface="Calibri" pitchFamily="34" charset="0"/>
-                          <a:ea typeface="Calibri" pitchFamily="34" charset="-122"/>
-                          <a:cs typeface="Calibri" pitchFamily="34" charset="-120"/>
-                        </a:rPr>
-                        <a:t>66–67%*</a:t>
-                      </a:r>
-                      <a:endParaRPr lang="en-US" sz="1300" dirty="0">
-                        <a:latin typeface="Calibri" charset="0"/>
-                        <a:ea typeface="Calibri" charset="0"/>
-                        <a:cs typeface="Calibri" charset="0"/>
-                      </a:endParaRPr>
-                    </a:p>
-                  </a:txBody>
-                  <a:tcPr marL="91440" marR="91440" marT="45720" marB="45720" anchor="ctr">
-                    <a:lnL w="12700" cap="flat" cmpd="sng" algn="ctr">
-                      <a:solidFill>
-                        <a:srgbClr val="DBE4E8"/>
-                      </a:solidFill>
-                      <a:prstDash val="solid"/>
-                      <a:round/>
-                      <a:headEnd type="none" w="med" len="med"/>
-                      <a:tailEnd type="none" w="med" len="med"/>
-                    </a:lnL>
-                    <a:lnR w="12700" cap="flat" cmpd="sng" algn="ctr">
-                      <a:solidFill>
-                        <a:srgbClr val="DBE4E8"/>
-                      </a:solidFill>
-                      <a:prstDash val="solid"/>
-                      <a:round/>
-                      <a:headEnd type="none" w="med" len="med"/>
-                      <a:tailEnd type="none" w="med" len="med"/>
-                    </a:lnR>
-                    <a:lnT w="12700" cap="flat" cmpd="sng" algn="ctr">
-                      <a:solidFill>
-                        <a:srgbClr val="DBE4E8"/>
-                      </a:solidFill>
-                      <a:prstDash val="solid"/>
-                      <a:round/>
-                      <a:headEnd type="none" w="med" len="med"/>
-                      <a:tailEnd type="none" w="med" len="med"/>
-                    </a:lnT>
-                    <a:lnB w="12700" cap="flat" cmpd="sng" algn="ctr">
-                      <a:solidFill>
-                        <a:srgbClr val="DBE4E8"/>
-                      </a:solidFill>
-                      <a:prstDash val="solid"/>
-                      <a:round/>
-                      <a:headEnd type="none" w="med" len="med"/>
-                      <a:tailEnd type="none" w="med" len="med"/>
-                    </a:lnB>
-                  </a:tcPr>
-                </a:tc>
-                <a:tc>
-                  <a:txBody>
-                    <a:bodyPr/>
-                    <a:lstStyle/>
-                    <a:p>
-                      <a:pPr algn="ctr" indent="0" marL="0">
-                        <a:buNone/>
-                      </a:pPr>
-                      <a:r>
-                        <a:rPr lang="en-US" sz="1300" dirty="0">
-                          <a:solidFill>
-                            <a:srgbClr val="33414F"/>
-                          </a:solidFill>
-                          <a:latin typeface="Calibri" pitchFamily="34" charset="0"/>
-                          <a:ea typeface="Calibri" pitchFamily="34" charset="-122"/>
-                          <a:cs typeface="Calibri" pitchFamily="34" charset="-120"/>
-                        </a:rPr>
-                        <a:t>— not addressed</a:t>
-                      </a:r>
-                      <a:endParaRPr lang="en-US" sz="1300" dirty="0">
-                        <a:latin typeface="Calibri" charset="0"/>
-                        <a:ea typeface="Calibri" charset="0"/>
-                        <a:cs typeface="Calibri" charset="0"/>
-                      </a:endParaRPr>
-                    </a:p>
-                  </a:txBody>
-                  <a:tcPr marL="91440" marR="91440" marT="45720" marB="45720" anchor="ctr">
-                    <a:lnL w="12700" cap="flat" cmpd="sng" algn="ctr">
-                      <a:solidFill>
-                        <a:srgbClr val="DBE4E8"/>
-                      </a:solidFill>
-                      <a:prstDash val="solid"/>
-                      <a:round/>
-                      <a:headEnd type="none" w="med" len="med"/>
-                      <a:tailEnd type="none" w="med" len="med"/>
-                    </a:lnL>
-                    <a:lnR w="12700" cap="flat" cmpd="sng" algn="ctr">
-                      <a:solidFill>
-                        <a:srgbClr val="DBE4E8"/>
-                      </a:solidFill>
-                      <a:prstDash val="solid"/>
-                      <a:round/>
-                      <a:headEnd type="none" w="med" len="med"/>
-                      <a:tailEnd type="none" w="med" len="med"/>
-                    </a:lnR>
-                    <a:lnT w="12700" cap="flat" cmpd="sng" algn="ctr">
-                      <a:solidFill>
-                        <a:srgbClr val="DBE4E8"/>
-                      </a:solidFill>
-                      <a:prstDash val="solid"/>
-                      <a:round/>
-                      <a:headEnd type="none" w="med" len="med"/>
-                      <a:tailEnd type="none" w="med" len="med"/>
-                    </a:lnT>
-                    <a:lnB w="12700" cap="flat" cmpd="sng" algn="ctr">
-                      <a:solidFill>
-                        <a:srgbClr val="DBE4E8"/>
-                      </a:solidFill>
-                      <a:prstDash val="solid"/>
-                      <a:round/>
-                      <a:headEnd type="none" w="med" len="med"/>
-                      <a:tailEnd type="none" w="med" len="med"/>
-                    </a:lnB>
-                  </a:tcPr>
-                </a:tc>
-                <a:tc>
-                  <a:txBody>
-                    <a:bodyPr/>
-                    <a:lstStyle/>
-                    <a:p>
-                      <a:pPr algn="ctr" indent="0" marL="0">
-                        <a:buNone/>
-                      </a:pPr>
-                      <a:r>
-                        <a:rPr lang="en-US" sz="1300" dirty="0">
-                          <a:solidFill>
-                            <a:srgbClr val="33414F"/>
-                          </a:solidFill>
-                          <a:latin typeface="Calibri" pitchFamily="34" charset="0"/>
-                          <a:ea typeface="Calibri" pitchFamily="34" charset="-122"/>
-                          <a:cs typeface="Calibri" pitchFamily="34" charset="-120"/>
-                        </a:rPr>
-                        <a:t>needed</a:t>
-                      </a:r>
-                      <a:endParaRPr lang="en-US" sz="1300" dirty="0">
-                        <a:latin typeface="Calibri" charset="0"/>
-                        <a:ea typeface="Calibri" charset="0"/>
-                        <a:cs typeface="Calibri" charset="0"/>
-                      </a:endParaRPr>
-                    </a:p>
-                  </a:txBody>
-                  <a:tcPr marL="91440" marR="91440" marT="45720" marB="45720" anchor="ctr">
-                    <a:lnL w="12700" cap="flat" cmpd="sng" algn="ctr">
-                      <a:solidFill>
-                        <a:srgbClr val="DBE4E8"/>
-                      </a:solidFill>
-                      <a:prstDash val="solid"/>
-                      <a:round/>
-                      <a:headEnd type="none" w="med" len="med"/>
-                      <a:tailEnd type="none" w="med" len="med"/>
-                    </a:lnL>
-                    <a:lnR w="12700" cap="flat" cmpd="sng" algn="ctr">
-                      <a:solidFill>
-                        <a:srgbClr val="DBE4E8"/>
-                      </a:solidFill>
-                      <a:prstDash val="solid"/>
-                      <a:round/>
-                      <a:headEnd type="none" w="med" len="med"/>
-                      <a:tailEnd type="none" w="med" len="med"/>
-                    </a:lnR>
-                    <a:lnT w="12700" cap="flat" cmpd="sng" algn="ctr">
-                      <a:solidFill>
-                        <a:srgbClr val="DBE4E8"/>
-                      </a:solidFill>
-                      <a:prstDash val="solid"/>
-                      <a:round/>
-                      <a:headEnd type="none" w="med" len="med"/>
-                      <a:tailEnd type="none" w="med" len="med"/>
-                    </a:lnT>
-                    <a:lnB w="12700" cap="flat" cmpd="sng" algn="ctr">
-                      <a:solidFill>
-                        <a:srgbClr val="DBE4E8"/>
-                      </a:solidFill>
-                      <a:prstDash val="solid"/>
-                      <a:round/>
-                      <a:headEnd type="none" w="med" len="med"/>
-                      <a:tailEnd type="none" w="med" len="med"/>
-                    </a:lnB>
-                  </a:tcPr>
-                </a:tc>
-              </a:tr>
-              <a:tr h="566928">
+              <a:tr h="548640">
                 <a:tc>
                   <a:txBody>
                     <a:bodyPr/>
@@ -18135,7 +17349,7 @@
                           <a:ea typeface="Calibri" pitchFamily="34" charset="-122"/>
                           <a:cs typeface="Calibri" pitchFamily="34" charset="-120"/>
                         </a:rPr>
-                        <a:t>SENTRY (ours)</a:t>
+                        <a:t>CodeBERT + SENTRY</a:t>
                       </a:r>
                       <a:endParaRPr lang="en-US" sz="1300" dirty="0">
                         <a:latin typeface="Calibri" charset="0"/>
@@ -18203,7 +17417,7 @@
                           <a:ea typeface="Calibri" pitchFamily="34" charset="-122"/>
                           <a:cs typeface="Calibri" pitchFamily="34" charset="-120"/>
                         </a:rPr>
-                        <a:t>~84%</a:t>
+                        <a:t>83.1%</a:t>
                       </a:r>
                       <a:endParaRPr lang="en-US" sz="1300" dirty="0">
                         <a:latin typeface="Calibri" charset="0"/>
@@ -18391,6 +17605,804 @@
                   </a:tcPr>
                 </a:tc>
               </a:tr>
+              <a:tr h="548640">
+                <a:tc>
+                  <a:txBody>
+                    <a:bodyPr/>
+                    <a:lstStyle/>
+                    <a:p>
+                      <a:pPr algn="ctr" indent="0" marL="0">
+                        <a:buNone/>
+                      </a:pPr>
+                      <a:r>
+                        <a:rPr lang="en-US" sz="1300" dirty="0">
+                          <a:solidFill>
+                            <a:srgbClr val="33414F"/>
+                          </a:solidFill>
+                          <a:latin typeface="Calibri" pitchFamily="34" charset="0"/>
+                          <a:ea typeface="Calibri" pitchFamily="34" charset="-122"/>
+                          <a:cs typeface="Calibri" pitchFamily="34" charset="-120"/>
+                        </a:rPr>
+                        <a:t>GraphCodeBERT — base</a:t>
+                      </a:r>
+                      <a:endParaRPr lang="en-US" sz="1300" dirty="0">
+                        <a:latin typeface="Calibri" charset="0"/>
+                        <a:ea typeface="Calibri" charset="0"/>
+                        <a:cs typeface="Calibri" charset="0"/>
+                      </a:endParaRPr>
+                    </a:p>
+                  </a:txBody>
+                  <a:tcPr marL="91440" marR="91440" marT="45720" marB="45720" anchor="ctr">
+                    <a:lnL w="12700" cap="flat" cmpd="sng" algn="ctr">
+                      <a:solidFill>
+                        <a:srgbClr val="DBE4E8"/>
+                      </a:solidFill>
+                      <a:prstDash val="solid"/>
+                      <a:round/>
+                      <a:headEnd type="none" w="med" len="med"/>
+                      <a:tailEnd type="none" w="med" len="med"/>
+                    </a:lnL>
+                    <a:lnR w="12700" cap="flat" cmpd="sng" algn="ctr">
+                      <a:solidFill>
+                        <a:srgbClr val="DBE4E8"/>
+                      </a:solidFill>
+                      <a:prstDash val="solid"/>
+                      <a:round/>
+                      <a:headEnd type="none" w="med" len="med"/>
+                      <a:tailEnd type="none" w="med" len="med"/>
+                    </a:lnR>
+                    <a:lnT w="12700" cap="flat" cmpd="sng" algn="ctr">
+                      <a:solidFill>
+                        <a:srgbClr val="DBE4E8"/>
+                      </a:solidFill>
+                      <a:prstDash val="solid"/>
+                      <a:round/>
+                      <a:headEnd type="none" w="med" len="med"/>
+                      <a:tailEnd type="none" w="med" len="med"/>
+                    </a:lnT>
+                    <a:lnB w="12700" cap="flat" cmpd="sng" algn="ctr">
+                      <a:solidFill>
+                        <a:srgbClr val="DBE4E8"/>
+                      </a:solidFill>
+                      <a:prstDash val="solid"/>
+                      <a:round/>
+                      <a:headEnd type="none" w="med" len="med"/>
+                      <a:tailEnd type="none" w="med" len="med"/>
+                    </a:lnB>
+                  </a:tcPr>
+                </a:tc>
+                <a:tc>
+                  <a:txBody>
+                    <a:bodyPr/>
+                    <a:lstStyle/>
+                    <a:p>
+                      <a:pPr algn="ctr" indent="0" marL="0">
+                        <a:buNone/>
+                      </a:pPr>
+                      <a:r>
+                        <a:rPr lang="en-US" sz="1300" dirty="0">
+                          <a:solidFill>
+                            <a:srgbClr val="33414F"/>
+                          </a:solidFill>
+                          <a:latin typeface="Calibri" pitchFamily="34" charset="0"/>
+                          <a:ea typeface="Calibri" pitchFamily="34" charset="-122"/>
+                          <a:cs typeface="Calibri" pitchFamily="34" charset="-120"/>
+                        </a:rPr>
+                        <a:t>80.6%</a:t>
+                      </a:r>
+                      <a:endParaRPr lang="en-US" sz="1300" dirty="0">
+                        <a:latin typeface="Calibri" charset="0"/>
+                        <a:ea typeface="Calibri" charset="0"/>
+                        <a:cs typeface="Calibri" charset="0"/>
+                      </a:endParaRPr>
+                    </a:p>
+                  </a:txBody>
+                  <a:tcPr marL="91440" marR="91440" marT="45720" marB="45720" anchor="ctr">
+                    <a:lnL w="12700" cap="flat" cmpd="sng" algn="ctr">
+                      <a:solidFill>
+                        <a:srgbClr val="DBE4E8"/>
+                      </a:solidFill>
+                      <a:prstDash val="solid"/>
+                      <a:round/>
+                      <a:headEnd type="none" w="med" len="med"/>
+                      <a:tailEnd type="none" w="med" len="med"/>
+                    </a:lnL>
+                    <a:lnR w="12700" cap="flat" cmpd="sng" algn="ctr">
+                      <a:solidFill>
+                        <a:srgbClr val="DBE4E8"/>
+                      </a:solidFill>
+                      <a:prstDash val="solid"/>
+                      <a:round/>
+                      <a:headEnd type="none" w="med" len="med"/>
+                      <a:tailEnd type="none" w="med" len="med"/>
+                    </a:lnR>
+                    <a:lnT w="12700" cap="flat" cmpd="sng" algn="ctr">
+                      <a:solidFill>
+                        <a:srgbClr val="DBE4E8"/>
+                      </a:solidFill>
+                      <a:prstDash val="solid"/>
+                      <a:round/>
+                      <a:headEnd type="none" w="med" len="med"/>
+                      <a:tailEnd type="none" w="med" len="med"/>
+                    </a:lnT>
+                    <a:lnB w="12700" cap="flat" cmpd="sng" algn="ctr">
+                      <a:solidFill>
+                        <a:srgbClr val="DBE4E8"/>
+                      </a:solidFill>
+                      <a:prstDash val="solid"/>
+                      <a:round/>
+                      <a:headEnd type="none" w="med" len="med"/>
+                      <a:tailEnd type="none" w="med" len="med"/>
+                    </a:lnB>
+                  </a:tcPr>
+                </a:tc>
+                <a:tc>
+                  <a:txBody>
+                    <a:bodyPr/>
+                    <a:lstStyle/>
+                    <a:p>
+                      <a:pPr algn="ctr" indent="0" marL="0">
+                        <a:buNone/>
+                      </a:pPr>
+                      <a:r>
+                        <a:rPr lang="en-US" sz="1300" dirty="0">
+                          <a:solidFill>
+                            <a:srgbClr val="33414F"/>
+                          </a:solidFill>
+                          <a:latin typeface="Calibri" pitchFamily="34" charset="0"/>
+                          <a:ea typeface="Calibri" pitchFamily="34" charset="-122"/>
+                          <a:cs typeface="Calibri" pitchFamily="34" charset="-120"/>
+                        </a:rPr>
+                        <a:t>✗ overconfident</a:t>
+                      </a:r>
+                      <a:endParaRPr lang="en-US" sz="1300" dirty="0">
+                        <a:latin typeface="Calibri" charset="0"/>
+                        <a:ea typeface="Calibri" charset="0"/>
+                        <a:cs typeface="Calibri" charset="0"/>
+                      </a:endParaRPr>
+                    </a:p>
+                  </a:txBody>
+                  <a:tcPr marL="91440" marR="91440" marT="45720" marB="45720" anchor="ctr">
+                    <a:lnL w="12700" cap="flat" cmpd="sng" algn="ctr">
+                      <a:solidFill>
+                        <a:srgbClr val="DBE4E8"/>
+                      </a:solidFill>
+                      <a:prstDash val="solid"/>
+                      <a:round/>
+                      <a:headEnd type="none" w="med" len="med"/>
+                      <a:tailEnd type="none" w="med" len="med"/>
+                    </a:lnL>
+                    <a:lnR w="12700" cap="flat" cmpd="sng" algn="ctr">
+                      <a:solidFill>
+                        <a:srgbClr val="DBE4E8"/>
+                      </a:solidFill>
+                      <a:prstDash val="solid"/>
+                      <a:round/>
+                      <a:headEnd type="none" w="med" len="med"/>
+                      <a:tailEnd type="none" w="med" len="med"/>
+                    </a:lnR>
+                    <a:lnT w="12700" cap="flat" cmpd="sng" algn="ctr">
+                      <a:solidFill>
+                        <a:srgbClr val="DBE4E8"/>
+                      </a:solidFill>
+                      <a:prstDash val="solid"/>
+                      <a:round/>
+                      <a:headEnd type="none" w="med" len="med"/>
+                      <a:tailEnd type="none" w="med" len="med"/>
+                    </a:lnT>
+                    <a:lnB w="12700" cap="flat" cmpd="sng" algn="ctr">
+                      <a:solidFill>
+                        <a:srgbClr val="DBE4E8"/>
+                      </a:solidFill>
+                      <a:prstDash val="solid"/>
+                      <a:round/>
+                      <a:headEnd type="none" w="med" len="med"/>
+                      <a:tailEnd type="none" w="med" len="med"/>
+                    </a:lnB>
+                  </a:tcPr>
+                </a:tc>
+                <a:tc>
+                  <a:txBody>
+                    <a:bodyPr/>
+                    <a:lstStyle/>
+                    <a:p>
+                      <a:pPr algn="ctr" indent="0" marL="0">
+                        <a:buNone/>
+                      </a:pPr>
+                      <a:r>
+                        <a:rPr lang="en-US" sz="1300" dirty="0">
+                          <a:solidFill>
+                            <a:srgbClr val="33414F"/>
+                          </a:solidFill>
+                          <a:latin typeface="Calibri" pitchFamily="34" charset="0"/>
+                          <a:ea typeface="Calibri" pitchFamily="34" charset="-122"/>
+                          <a:cs typeface="Calibri" pitchFamily="34" charset="-120"/>
+                        </a:rPr>
+                        <a:t>—</a:t>
+                      </a:r>
+                      <a:endParaRPr lang="en-US" sz="1300" dirty="0">
+                        <a:latin typeface="Calibri" charset="0"/>
+                        <a:ea typeface="Calibri" charset="0"/>
+                        <a:cs typeface="Calibri" charset="0"/>
+                      </a:endParaRPr>
+                    </a:p>
+                  </a:txBody>
+                  <a:tcPr marL="91440" marR="91440" marT="45720" marB="45720" anchor="ctr">
+                    <a:lnL w="12700" cap="flat" cmpd="sng" algn="ctr">
+                      <a:solidFill>
+                        <a:srgbClr val="DBE4E8"/>
+                      </a:solidFill>
+                      <a:prstDash val="solid"/>
+                      <a:round/>
+                      <a:headEnd type="none" w="med" len="med"/>
+                      <a:tailEnd type="none" w="med" len="med"/>
+                    </a:lnL>
+                    <a:lnR w="12700" cap="flat" cmpd="sng" algn="ctr">
+                      <a:solidFill>
+                        <a:srgbClr val="DBE4E8"/>
+                      </a:solidFill>
+                      <a:prstDash val="solid"/>
+                      <a:round/>
+                      <a:headEnd type="none" w="med" len="med"/>
+                      <a:tailEnd type="none" w="med" len="med"/>
+                    </a:lnR>
+                    <a:lnT w="12700" cap="flat" cmpd="sng" algn="ctr">
+                      <a:solidFill>
+                        <a:srgbClr val="DBE4E8"/>
+                      </a:solidFill>
+                      <a:prstDash val="solid"/>
+                      <a:round/>
+                      <a:headEnd type="none" w="med" len="med"/>
+                      <a:tailEnd type="none" w="med" len="med"/>
+                    </a:lnT>
+                    <a:lnB w="12700" cap="flat" cmpd="sng" algn="ctr">
+                      <a:solidFill>
+                        <a:srgbClr val="DBE4E8"/>
+                      </a:solidFill>
+                      <a:prstDash val="solid"/>
+                      <a:round/>
+                      <a:headEnd type="none" w="med" len="med"/>
+                      <a:tailEnd type="none" w="med" len="med"/>
+                    </a:lnB>
+                  </a:tcPr>
+                </a:tc>
+              </a:tr>
+              <a:tr h="548640">
+                <a:tc>
+                  <a:txBody>
+                    <a:bodyPr/>
+                    <a:lstStyle/>
+                    <a:p>
+                      <a:pPr algn="ctr" indent="0" marL="0">
+                        <a:buNone/>
+                      </a:pPr>
+                      <a:r>
+                        <a:rPr lang="en-US" sz="1300" b="1" dirty="0">
+                          <a:solidFill>
+                            <a:srgbClr val="16324F"/>
+                          </a:solidFill>
+                          <a:latin typeface="Calibri" pitchFamily="34" charset="0"/>
+                          <a:ea typeface="Calibri" pitchFamily="34" charset="-122"/>
+                          <a:cs typeface="Calibri" pitchFamily="34" charset="-120"/>
+                        </a:rPr>
+                        <a:t>GraphCodeBERT + SENTRY</a:t>
+                      </a:r>
+                      <a:endParaRPr lang="en-US" sz="1300" dirty="0">
+                        <a:latin typeface="Calibri" charset="0"/>
+                        <a:ea typeface="Calibri" charset="0"/>
+                        <a:cs typeface="Calibri" charset="0"/>
+                      </a:endParaRPr>
+                    </a:p>
+                  </a:txBody>
+                  <a:tcPr marL="91440" marR="91440" marT="45720" marB="45720" anchor="ctr">
+                    <a:lnL w="12700" cap="flat" cmpd="sng" algn="ctr">
+                      <a:solidFill>
+                        <a:srgbClr val="DBE4E8"/>
+                      </a:solidFill>
+                      <a:prstDash val="solid"/>
+                      <a:round/>
+                      <a:headEnd type="none" w="med" len="med"/>
+                      <a:tailEnd type="none" w="med" len="med"/>
+                    </a:lnL>
+                    <a:lnR w="12700" cap="flat" cmpd="sng" algn="ctr">
+                      <a:solidFill>
+                        <a:srgbClr val="DBE4E8"/>
+                      </a:solidFill>
+                      <a:prstDash val="solid"/>
+                      <a:round/>
+                      <a:headEnd type="none" w="med" len="med"/>
+                      <a:tailEnd type="none" w="med" len="med"/>
+                    </a:lnR>
+                    <a:lnT w="12700" cap="flat" cmpd="sng" algn="ctr">
+                      <a:solidFill>
+                        <a:srgbClr val="DBE4E8"/>
+                      </a:solidFill>
+                      <a:prstDash val="solid"/>
+                      <a:round/>
+                      <a:headEnd type="none" w="med" len="med"/>
+                      <a:tailEnd type="none" w="med" len="med"/>
+                    </a:lnT>
+                    <a:lnB w="12700" cap="flat" cmpd="sng" algn="ctr">
+                      <a:solidFill>
+                        <a:srgbClr val="DBE4E8"/>
+                      </a:solidFill>
+                      <a:prstDash val="solid"/>
+                      <a:round/>
+                      <a:headEnd type="none" w="med" len="med"/>
+                      <a:tailEnd type="none" w="med" len="med"/>
+                    </a:lnB>
+                    <a:solidFill>
+                      <a:srgbClr val="DCEEF0"/>
+                    </a:solidFill>
+                  </a:tcPr>
+                </a:tc>
+                <a:tc>
+                  <a:txBody>
+                    <a:bodyPr/>
+                    <a:lstStyle/>
+                    <a:p>
+                      <a:pPr algn="ctr" indent="0" marL="0">
+                        <a:buNone/>
+                      </a:pPr>
+                      <a:r>
+                        <a:rPr lang="en-US" sz="1300" b="1" dirty="0">
+                          <a:solidFill>
+                            <a:srgbClr val="16324F"/>
+                          </a:solidFill>
+                          <a:latin typeface="Calibri" pitchFamily="34" charset="0"/>
+                          <a:ea typeface="Calibri" pitchFamily="34" charset="-122"/>
+                          <a:cs typeface="Calibri" pitchFamily="34" charset="-120"/>
+                        </a:rPr>
+                        <a:t>83.5%</a:t>
+                      </a:r>
+                      <a:endParaRPr lang="en-US" sz="1300" dirty="0">
+                        <a:latin typeface="Calibri" charset="0"/>
+                        <a:ea typeface="Calibri" charset="0"/>
+                        <a:cs typeface="Calibri" charset="0"/>
+                      </a:endParaRPr>
+                    </a:p>
+                  </a:txBody>
+                  <a:tcPr marL="91440" marR="91440" marT="45720" marB="45720" anchor="ctr">
+                    <a:lnL w="12700" cap="flat" cmpd="sng" algn="ctr">
+                      <a:solidFill>
+                        <a:srgbClr val="DBE4E8"/>
+                      </a:solidFill>
+                      <a:prstDash val="solid"/>
+                      <a:round/>
+                      <a:headEnd type="none" w="med" len="med"/>
+                      <a:tailEnd type="none" w="med" len="med"/>
+                    </a:lnL>
+                    <a:lnR w="12700" cap="flat" cmpd="sng" algn="ctr">
+                      <a:solidFill>
+                        <a:srgbClr val="DBE4E8"/>
+                      </a:solidFill>
+                      <a:prstDash val="solid"/>
+                      <a:round/>
+                      <a:headEnd type="none" w="med" len="med"/>
+                      <a:tailEnd type="none" w="med" len="med"/>
+                    </a:lnR>
+                    <a:lnT w="12700" cap="flat" cmpd="sng" algn="ctr">
+                      <a:solidFill>
+                        <a:srgbClr val="DBE4E8"/>
+                      </a:solidFill>
+                      <a:prstDash val="solid"/>
+                      <a:round/>
+                      <a:headEnd type="none" w="med" len="med"/>
+                      <a:tailEnd type="none" w="med" len="med"/>
+                    </a:lnT>
+                    <a:lnB w="12700" cap="flat" cmpd="sng" algn="ctr">
+                      <a:solidFill>
+                        <a:srgbClr val="DBE4E8"/>
+                      </a:solidFill>
+                      <a:prstDash val="solid"/>
+                      <a:round/>
+                      <a:headEnd type="none" w="med" len="med"/>
+                      <a:tailEnd type="none" w="med" len="med"/>
+                    </a:lnB>
+                    <a:solidFill>
+                      <a:srgbClr val="DCEEF0"/>
+                    </a:solidFill>
+                  </a:tcPr>
+                </a:tc>
+                <a:tc>
+                  <a:txBody>
+                    <a:bodyPr/>
+                    <a:lstStyle/>
+                    <a:p>
+                      <a:pPr algn="ctr" indent="0" marL="0">
+                        <a:buNone/>
+                      </a:pPr>
+                      <a:r>
+                        <a:rPr lang="en-US" sz="1300" b="1" dirty="0">
+                          <a:solidFill>
+                            <a:srgbClr val="2E8B57"/>
+                          </a:solidFill>
+                          <a:latin typeface="Calibri" pitchFamily="34" charset="0"/>
+                          <a:ea typeface="Calibri" pitchFamily="34" charset="-122"/>
+                          <a:cs typeface="Calibri" pitchFamily="34" charset="-120"/>
+                        </a:rPr>
+                        <a:t>✓ calibrated</a:t>
+                      </a:r>
+                      <a:endParaRPr lang="en-US" sz="1300" dirty="0">
+                        <a:latin typeface="Calibri" charset="0"/>
+                        <a:ea typeface="Calibri" charset="0"/>
+                        <a:cs typeface="Calibri" charset="0"/>
+                      </a:endParaRPr>
+                    </a:p>
+                  </a:txBody>
+                  <a:tcPr marL="91440" marR="91440" marT="45720" marB="45720" anchor="ctr">
+                    <a:lnL w="12700" cap="flat" cmpd="sng" algn="ctr">
+                      <a:solidFill>
+                        <a:srgbClr val="DBE4E8"/>
+                      </a:solidFill>
+                      <a:prstDash val="solid"/>
+                      <a:round/>
+                      <a:headEnd type="none" w="med" len="med"/>
+                      <a:tailEnd type="none" w="med" len="med"/>
+                    </a:lnL>
+                    <a:lnR w="12700" cap="flat" cmpd="sng" algn="ctr">
+                      <a:solidFill>
+                        <a:srgbClr val="DBE4E8"/>
+                      </a:solidFill>
+                      <a:prstDash val="solid"/>
+                      <a:round/>
+                      <a:headEnd type="none" w="med" len="med"/>
+                      <a:tailEnd type="none" w="med" len="med"/>
+                    </a:lnR>
+                    <a:lnT w="12700" cap="flat" cmpd="sng" algn="ctr">
+                      <a:solidFill>
+                        <a:srgbClr val="DBE4E8"/>
+                      </a:solidFill>
+                      <a:prstDash val="solid"/>
+                      <a:round/>
+                      <a:headEnd type="none" w="med" len="med"/>
+                      <a:tailEnd type="none" w="med" len="med"/>
+                    </a:lnT>
+                    <a:lnB w="12700" cap="flat" cmpd="sng" algn="ctr">
+                      <a:solidFill>
+                        <a:srgbClr val="DBE4E8"/>
+                      </a:solidFill>
+                      <a:prstDash val="solid"/>
+                      <a:round/>
+                      <a:headEnd type="none" w="med" len="med"/>
+                      <a:tailEnd type="none" w="med" len="med"/>
+                    </a:lnB>
+                    <a:solidFill>
+                      <a:srgbClr val="DCEEF0"/>
+                    </a:solidFill>
+                  </a:tcPr>
+                </a:tc>
+                <a:tc>
+                  <a:txBody>
+                    <a:bodyPr/>
+                    <a:lstStyle/>
+                    <a:p>
+                      <a:pPr algn="ctr" indent="0" marL="0">
+                        <a:buNone/>
+                      </a:pPr>
+                      <a:r>
+                        <a:rPr lang="en-US" sz="1300" b="1" dirty="0">
+                          <a:solidFill>
+                            <a:srgbClr val="16324F"/>
+                          </a:solidFill>
+                          <a:latin typeface="Calibri" pitchFamily="34" charset="0"/>
+                          <a:ea typeface="Calibri" pitchFamily="34" charset="-122"/>
+                          <a:cs typeface="Calibri" pitchFamily="34" charset="-120"/>
+                        </a:rPr>
+                        <a:t>none</a:t>
+                      </a:r>
+                      <a:endParaRPr lang="en-US" sz="1300" dirty="0">
+                        <a:latin typeface="Calibri" charset="0"/>
+                        <a:ea typeface="Calibri" charset="0"/>
+                        <a:cs typeface="Calibri" charset="0"/>
+                      </a:endParaRPr>
+                    </a:p>
+                  </a:txBody>
+                  <a:tcPr marL="91440" marR="91440" marT="45720" marB="45720" anchor="ctr">
+                    <a:lnL w="12700" cap="flat" cmpd="sng" algn="ctr">
+                      <a:solidFill>
+                        <a:srgbClr val="DBE4E8"/>
+                      </a:solidFill>
+                      <a:prstDash val="solid"/>
+                      <a:round/>
+                      <a:headEnd type="none" w="med" len="med"/>
+                      <a:tailEnd type="none" w="med" len="med"/>
+                    </a:lnL>
+                    <a:lnR w="12700" cap="flat" cmpd="sng" algn="ctr">
+                      <a:solidFill>
+                        <a:srgbClr val="DBE4E8"/>
+                      </a:solidFill>
+                      <a:prstDash val="solid"/>
+                      <a:round/>
+                      <a:headEnd type="none" w="med" len="med"/>
+                      <a:tailEnd type="none" w="med" len="med"/>
+                    </a:lnR>
+                    <a:lnT w="12700" cap="flat" cmpd="sng" algn="ctr">
+                      <a:solidFill>
+                        <a:srgbClr val="DBE4E8"/>
+                      </a:solidFill>
+                      <a:prstDash val="solid"/>
+                      <a:round/>
+                      <a:headEnd type="none" w="med" len="med"/>
+                      <a:tailEnd type="none" w="med" len="med"/>
+                    </a:lnT>
+                    <a:lnB w="12700" cap="flat" cmpd="sng" algn="ctr">
+                      <a:solidFill>
+                        <a:srgbClr val="DBE4E8"/>
+                      </a:solidFill>
+                      <a:prstDash val="solid"/>
+                      <a:round/>
+                      <a:headEnd type="none" w="med" len="med"/>
+                      <a:tailEnd type="none" w="med" len="med"/>
+                    </a:lnB>
+                    <a:solidFill>
+                      <a:srgbClr val="DCEEF0"/>
+                    </a:solidFill>
+                  </a:tcPr>
+                </a:tc>
+              </a:tr>
+              <a:tr h="548640">
+                <a:tc>
+                  <a:txBody>
+                    <a:bodyPr/>
+                    <a:lstStyle/>
+                    <a:p>
+                      <a:pPr algn="ctr" indent="0" marL="0">
+                        <a:buNone/>
+                      </a:pPr>
+                      <a:r>
+                        <a:rPr lang="en-US" sz="1300" dirty="0">
+                          <a:solidFill>
+                            <a:srgbClr val="33414F"/>
+                          </a:solidFill>
+                          <a:latin typeface="Calibri" pitchFamily="34" charset="0"/>
+                          <a:ea typeface="Calibri" pitchFamily="34" charset="-122"/>
+                          <a:cs typeface="Calibri" pitchFamily="34" charset="-120"/>
+                        </a:rPr>
+                        <a:t>CodeImprove (ICSE’25, input-side)</a:t>
+                      </a:r>
+                      <a:endParaRPr lang="en-US" sz="1300" dirty="0">
+                        <a:latin typeface="Calibri" charset="0"/>
+                        <a:ea typeface="Calibri" charset="0"/>
+                        <a:cs typeface="Calibri" charset="0"/>
+                      </a:endParaRPr>
+                    </a:p>
+                  </a:txBody>
+                  <a:tcPr marL="91440" marR="91440" marT="45720" marB="45720" anchor="ctr">
+                    <a:lnL w="12700" cap="flat" cmpd="sng" algn="ctr">
+                      <a:solidFill>
+                        <a:srgbClr val="DBE4E8"/>
+                      </a:solidFill>
+                      <a:prstDash val="solid"/>
+                      <a:round/>
+                      <a:headEnd type="none" w="med" len="med"/>
+                      <a:tailEnd type="none" w="med" len="med"/>
+                    </a:lnL>
+                    <a:lnR w="12700" cap="flat" cmpd="sng" algn="ctr">
+                      <a:solidFill>
+                        <a:srgbClr val="DBE4E8"/>
+                      </a:solidFill>
+                      <a:prstDash val="solid"/>
+                      <a:round/>
+                      <a:headEnd type="none" w="med" len="med"/>
+                      <a:tailEnd type="none" w="med" len="med"/>
+                    </a:lnR>
+                    <a:lnT w="12700" cap="flat" cmpd="sng" algn="ctr">
+                      <a:solidFill>
+                        <a:srgbClr val="DBE4E8"/>
+                      </a:solidFill>
+                      <a:prstDash val="solid"/>
+                      <a:round/>
+                      <a:headEnd type="none" w="med" len="med"/>
+                      <a:tailEnd type="none" w="med" len="med"/>
+                    </a:lnT>
+                    <a:lnB w="12700" cap="flat" cmpd="sng" algn="ctr">
+                      <a:solidFill>
+                        <a:srgbClr val="DBE4E8"/>
+                      </a:solidFill>
+                      <a:prstDash val="solid"/>
+                      <a:round/>
+                      <a:headEnd type="none" w="med" len="med"/>
+                      <a:tailEnd type="none" w="med" len="med"/>
+                    </a:lnB>
+                  </a:tcPr>
+                </a:tc>
+                <a:tc>
+                  <a:txBody>
+                    <a:bodyPr/>
+                    <a:lstStyle/>
+                    <a:p>
+                      <a:pPr algn="ctr" indent="0" marL="0">
+                        <a:buNone/>
+                      </a:pPr>
+                      <a:r>
+                        <a:rPr lang="en-US" sz="1300" dirty="0">
+                          <a:solidFill>
+                            <a:srgbClr val="33414F"/>
+                          </a:solidFill>
+                          <a:latin typeface="Calibri" pitchFamily="34" charset="0"/>
+                          <a:ea typeface="Calibri" pitchFamily="34" charset="-122"/>
+                          <a:cs typeface="Calibri" pitchFamily="34" charset="-120"/>
+                        </a:rPr>
+                        <a:t>81.9%</a:t>
+                      </a:r>
+                      <a:endParaRPr lang="en-US" sz="1300" dirty="0">
+                        <a:latin typeface="Calibri" charset="0"/>
+                        <a:ea typeface="Calibri" charset="0"/>
+                        <a:cs typeface="Calibri" charset="0"/>
+                      </a:endParaRPr>
+                    </a:p>
+                  </a:txBody>
+                  <a:tcPr marL="91440" marR="91440" marT="45720" marB="45720" anchor="ctr">
+                    <a:lnL w="12700" cap="flat" cmpd="sng" algn="ctr">
+                      <a:solidFill>
+                        <a:srgbClr val="DBE4E8"/>
+                      </a:solidFill>
+                      <a:prstDash val="solid"/>
+                      <a:round/>
+                      <a:headEnd type="none" w="med" len="med"/>
+                      <a:tailEnd type="none" w="med" len="med"/>
+                    </a:lnL>
+                    <a:lnR w="12700" cap="flat" cmpd="sng" algn="ctr">
+                      <a:solidFill>
+                        <a:srgbClr val="DBE4E8"/>
+                      </a:solidFill>
+                      <a:prstDash val="solid"/>
+                      <a:round/>
+                      <a:headEnd type="none" w="med" len="med"/>
+                      <a:tailEnd type="none" w="med" len="med"/>
+                    </a:lnR>
+                    <a:lnT w="12700" cap="flat" cmpd="sng" algn="ctr">
+                      <a:solidFill>
+                        <a:srgbClr val="DBE4E8"/>
+                      </a:solidFill>
+                      <a:prstDash val="solid"/>
+                      <a:round/>
+                      <a:headEnd type="none" w="med" len="med"/>
+                      <a:tailEnd type="none" w="med" len="med"/>
+                    </a:lnT>
+                    <a:lnB w="12700" cap="flat" cmpd="sng" algn="ctr">
+                      <a:solidFill>
+                        <a:srgbClr val="DBE4E8"/>
+                      </a:solidFill>
+                      <a:prstDash val="solid"/>
+                      <a:round/>
+                      <a:headEnd type="none" w="med" len="med"/>
+                      <a:tailEnd type="none" w="med" len="med"/>
+                    </a:lnB>
+                  </a:tcPr>
+                </a:tc>
+                <a:tc>
+                  <a:txBody>
+                    <a:bodyPr/>
+                    <a:lstStyle/>
+                    <a:p>
+                      <a:pPr algn="ctr" indent="0" marL="0">
+                        <a:buNone/>
+                      </a:pPr>
+                      <a:r>
+                        <a:rPr lang="en-US" sz="1300" dirty="0">
+                          <a:solidFill>
+                            <a:srgbClr val="33414F"/>
+                          </a:solidFill>
+                          <a:latin typeface="Calibri" pitchFamily="34" charset="0"/>
+                          <a:ea typeface="Calibri" pitchFamily="34" charset="-122"/>
+                          <a:cs typeface="Calibri" pitchFamily="34" charset="-120"/>
+                        </a:rPr>
+                        <a:t>— not addressed</a:t>
+                      </a:r>
+                      <a:endParaRPr lang="en-US" sz="1300" dirty="0">
+                        <a:latin typeface="Calibri" charset="0"/>
+                        <a:ea typeface="Calibri" charset="0"/>
+                        <a:cs typeface="Calibri" charset="0"/>
+                      </a:endParaRPr>
+                    </a:p>
+                  </a:txBody>
+                  <a:tcPr marL="91440" marR="91440" marT="45720" marB="45720" anchor="ctr">
+                    <a:lnL w="12700" cap="flat" cmpd="sng" algn="ctr">
+                      <a:solidFill>
+                        <a:srgbClr val="DBE4E8"/>
+                      </a:solidFill>
+                      <a:prstDash val="solid"/>
+                      <a:round/>
+                      <a:headEnd type="none" w="med" len="med"/>
+                      <a:tailEnd type="none" w="med" len="med"/>
+                    </a:lnL>
+                    <a:lnR w="12700" cap="flat" cmpd="sng" algn="ctr">
+                      <a:solidFill>
+                        <a:srgbClr val="DBE4E8"/>
+                      </a:solidFill>
+                      <a:prstDash val="solid"/>
+                      <a:round/>
+                      <a:headEnd type="none" w="med" len="med"/>
+                      <a:tailEnd type="none" w="med" len="med"/>
+                    </a:lnR>
+                    <a:lnT w="12700" cap="flat" cmpd="sng" algn="ctr">
+                      <a:solidFill>
+                        <a:srgbClr val="DBE4E8"/>
+                      </a:solidFill>
+                      <a:prstDash val="solid"/>
+                      <a:round/>
+                      <a:headEnd type="none" w="med" len="med"/>
+                      <a:tailEnd type="none" w="med" len="med"/>
+                    </a:lnT>
+                    <a:lnB w="12700" cap="flat" cmpd="sng" algn="ctr">
+                      <a:solidFill>
+                        <a:srgbClr val="DBE4E8"/>
+                      </a:solidFill>
+                      <a:prstDash val="solid"/>
+                      <a:round/>
+                      <a:headEnd type="none" w="med" len="med"/>
+                      <a:tailEnd type="none" w="med" len="med"/>
+                    </a:lnB>
+                  </a:tcPr>
+                </a:tc>
+                <a:tc>
+                  <a:txBody>
+                    <a:bodyPr/>
+                    <a:lstStyle/>
+                    <a:p>
+                      <a:pPr algn="ctr" indent="0" marL="0">
+                        <a:buNone/>
+                      </a:pPr>
+                      <a:r>
+                        <a:rPr lang="en-US" sz="1300" dirty="0">
+                          <a:solidFill>
+                            <a:srgbClr val="33414F"/>
+                          </a:solidFill>
+                          <a:latin typeface="Calibri" pitchFamily="34" charset="0"/>
+                          <a:ea typeface="Calibri" pitchFamily="34" charset="-122"/>
+                          <a:cs typeface="Calibri" pitchFamily="34" charset="-120"/>
+                        </a:rPr>
+                        <a:t>none</a:t>
+                      </a:r>
+                      <a:endParaRPr lang="en-US" sz="1300" dirty="0">
+                        <a:latin typeface="Calibri" charset="0"/>
+                        <a:ea typeface="Calibri" charset="0"/>
+                        <a:cs typeface="Calibri" charset="0"/>
+                      </a:endParaRPr>
+                    </a:p>
+                  </a:txBody>
+                  <a:tcPr marL="91440" marR="91440" marT="45720" marB="45720" anchor="ctr">
+                    <a:lnL w="12700" cap="flat" cmpd="sng" algn="ctr">
+                      <a:solidFill>
+                        <a:srgbClr val="DBE4E8"/>
+                      </a:solidFill>
+                      <a:prstDash val="solid"/>
+                      <a:round/>
+                      <a:headEnd type="none" w="med" len="med"/>
+                      <a:tailEnd type="none" w="med" len="med"/>
+                    </a:lnL>
+                    <a:lnR w="12700" cap="flat" cmpd="sng" algn="ctr">
+                      <a:solidFill>
+                        <a:srgbClr val="DBE4E8"/>
+                      </a:solidFill>
+                      <a:prstDash val="solid"/>
+                      <a:round/>
+                      <a:headEnd type="none" w="med" len="med"/>
+                      <a:tailEnd type="none" w="med" len="med"/>
+                    </a:lnR>
+                    <a:lnT w="12700" cap="flat" cmpd="sng" algn="ctr">
+                      <a:solidFill>
+                        <a:srgbClr val="DBE4E8"/>
+                      </a:solidFill>
+                      <a:prstDash val="solid"/>
+                      <a:round/>
+                      <a:headEnd type="none" w="med" len="med"/>
+                      <a:tailEnd type="none" w="med" len="med"/>
+                    </a:lnT>
+                    <a:lnB w="12700" cap="flat" cmpd="sng" algn="ctr">
+                      <a:solidFill>
+                        <a:srgbClr val="DBE4E8"/>
+                      </a:solidFill>
+                      <a:prstDash val="solid"/>
+                      <a:round/>
+                      <a:headEnd type="none" w="med" len="med"/>
+                      <a:tailEnd type="none" w="med" len="med"/>
+                    </a:lnB>
+                  </a:tcPr>
+                </a:tc>
+              </a:tr>
             </a:tbl>
           </a:graphicData>
         </a:graphic>
@@ -18403,8 +18415,8 @@
         </p:nvSpPr>
         <p:spPr>
           <a:xfrm>
-            <a:off x="640080" y="5989320"/>
-            <a:ext cx="10881360" cy="457200"/>
+            <a:off x="640080" y="5943600"/>
+            <a:ext cx="10881360" cy="548640"/>
           </a:xfrm>
           <a:prstGeom prst="rect">
             <a:avLst/>
@@ -18428,7 +18440,7 @@
                 <a:ea typeface="Calibri" pitchFamily="34" charset="-122"/>
                 <a:cs typeface="Calibri" pitchFamily="34" charset="-120"/>
               </a:rPr>
-              <a:t>* vulnerability task. SENTRY adds calibration and reliability-gated accuracy on a comparable base — complementary to post-hoc calibration (incl. kNN-UE, NAACL’25) and to input-side CodeImprove.</a:t>
+              <a:t>Defect prediction (CodeChef). On vulnerability detection SENTRY matches the base detector (~61%) and adds calibration + abstention — we do not claim accuracy SOTA there. Complementary to post-hoc calibration (incl. kNN-UE, NAACL’25) and to input-side CodeImprove.</a:t>
             </a:r>
             <a:endParaRPr lang="en-US" sz="1100" dirty="0"/>
           </a:p>
@@ -20874,7 +20886,7 @@
                 <a:ea typeface="Calibri" pitchFamily="34" charset="-122"/>
                 <a:cs typeface="Calibri" pitchFamily="34" charset="-120"/>
               </a:rPr>
-              <a:t>They announce “99% sure” — and are still wrong.</a:t>
+              <a:t>They report high confidence — and are still wrong.</a:t>
             </a:r>
             <a:endParaRPr lang="en-US" sz="1800" dirty="0"/>
           </a:p>
@@ -20991,7 +21003,7 @@
                 <a:ea typeface="Calibri" pitchFamily="34" charset="-122"/>
                 <a:cs typeface="Calibri" pitchFamily="34" charset="-120"/>
               </a:rPr>
-              <a:t>Says: 99% confident</a:t>
+              <a:t>Says: 81% confident</a:t>
             </a:r>
             <a:endParaRPr lang="en-US" sz="1600" dirty="0"/>
           </a:p>
@@ -21028,7 +21040,7 @@
         <p:spPr>
           <a:xfrm>
             <a:off x="960120" y="4297680"/>
-            <a:ext cx="4069080" cy="310896"/>
+            <a:ext cx="2542032" cy="310896"/>
           </a:xfrm>
           <a:prstGeom prst="roundRect">
             <a:avLst>
@@ -21050,7 +21062,7 @@
         <p:spPr>
           <a:xfrm>
             <a:off x="960120" y="4709160"/>
-            <a:ext cx="4114800" cy="365760"/>
+            <a:ext cx="4297680" cy="365760"/>
           </a:xfrm>
           <a:prstGeom prst="rect">
             <a:avLst/>
@@ -21066,7 +21078,7 @@
               <a:buNone/>
             </a:pPr>
             <a:r>
-              <a:rPr lang="en-US" sz="1300" i="1" dirty="0">
+              <a:rPr lang="en-US" sz="1200" i="1" dirty="0">
                 <a:solidFill>
                   <a:srgbClr val="6B7785"/>
                 </a:solidFill>
@@ -21074,9 +21086,9 @@
                 <a:ea typeface="Calibri" pitchFamily="34" charset="-122"/>
                 <a:cs typeface="Calibri" pitchFamily="34" charset="-120"/>
               </a:rPr>
-              <a:t>Actually right far less often</a:t>
-            </a:r>
-            <a:endParaRPr lang="en-US" sz="1300" dirty="0"/>
+              <a:t>Right only 61% of the time (CodeBERT, vulnerability)</a:t>
+            </a:r>
+            <a:endParaRPr lang="en-US" sz="1200" dirty="0"/>
           </a:p>
         </p:txBody>
       </p:sp>

</xml_diff>